<commit_message>
Prepare usage tips presentation materials
</commit_message>
<xml_diff>
--- a/docs/zh/09-Claude Code 使用技巧与注意事项-WPS兼容版.pptx
+++ b/docs/zh/09-Claude Code 使用技巧与注意事项-WPS兼容版.pptx
@@ -17,6 +17,7 @@
     <p:sldId id="265" r:id="rId16"/>
     <p:sldId id="266" r:id="rId17"/>
     <p:sldId id="267" r:id="rId18"/>
+    <p:sldId id="268" r:id="rId19"/>
   </p:sldIdLst>
   <p:sldSz cx="12191695" cy="6858000" type="screen4x3"/>
   <p:notesSz cx="6858000" cy="9144000"/>
@@ -3209,7 +3210,7 @@
                 </a:solidFill>
                 <a:latin typeface="Arial"/>
               </a:rPr>
-              <a:t>关注点：怎么提需求、怎么控制行为、怎么避免常见误用</a:t>
+              <a:t>先解释 Claude Code 从工程上是什么，再解释怎样用会更稳</a:t>
             </a:r>
           </a:p>
           <a:p>
@@ -3225,7 +3226,7 @@
                 </a:solidFill>
                 <a:latin typeface="Arial"/>
               </a:rPr>
-              <a:t>每条技巧都给出源码支撑，不只讲经验</a:t>
+              <a:t>每条技巧都附源码支撑，不只讲经验</a:t>
             </a:r>
           </a:p>
         </p:txBody>
@@ -3285,7 +3286,7 @@
                 </a:solidFill>
                 <a:latin typeface="Arial"/>
               </a:rPr>
-              <a:t>技巧 8：高风险动作要显式要求先确认</a:t>
+              <a:t>技巧 6：高风险动作要显式要求先确认</a:t>
             </a:r>
           </a:p>
         </p:txBody>
@@ -3599,7 +3600,7 @@
                 </a:solidFill>
                 <a:latin typeface="Arial"/>
               </a:rPr>
-              <a:t>技巧 9：做方案时，先走 Plan Mode 风格</a:t>
+              <a:t>两个进阶技巧</a:t>
             </a:r>
           </a:p>
         </p:txBody>
@@ -3649,211 +3650,105 @@
       </p:sp>
       <p:sp>
         <p:nvSpPr>
-          <p:cNvPr id="4" name="Rounded Rectangle 3"/>
-          <p:cNvSpPr/>
+          <p:cNvPr id="4" name="TextBox 3"/>
+          <p:cNvSpPr txBox="1"/>
           <p:nvPr/>
         </p:nvSpPr>
         <p:spPr>
           <a:xfrm>
-            <a:off x="731520" y="1508760"/>
-            <a:ext cx="3291840" cy="1828800"/>
-          </a:xfrm>
-          <a:prstGeom prst="roundRect">
+            <a:off x="777240" y="1508760"/>
+            <a:ext cx="10241280" cy="4389120"/>
+          </a:xfrm>
+          <a:prstGeom prst="rect">
             <a:avLst/>
           </a:prstGeom>
-          <a:solidFill>
-            <a:srgbClr val="FFFFFF"/>
-          </a:solidFill>
-          <a:ln>
-            <a:solidFill>
-              <a:srgbClr val="205295"/>
-            </a:solidFill>
-          </a:ln>
-        </p:spPr>
-        <p:style>
-          <a:lnRef idx="1">
-            <a:schemeClr val="accent1"/>
-          </a:lnRef>
-          <a:fillRef idx="3">
-            <a:schemeClr val="accent1"/>
-          </a:fillRef>
-          <a:effectRef idx="2">
-            <a:schemeClr val="accent1"/>
-          </a:effectRef>
-          <a:fontRef idx="minor">
-            <a:schemeClr val="lt1"/>
-          </a:fontRef>
-        </p:style>
-        <p:txBody>
-          <a:bodyPr rtlCol="0" anchor="ctr" wrap="square" lIns="76200" rIns="76200" tIns="50800" bIns="50800"/>
-          <a:lstStyle/>
-          <a:p>
-            <a:pPr algn="ctr"/>
-            <a:r>
-              <a:rPr sz="1600" b="1">
-                <a:solidFill>
-                  <a:srgbClr val="205295"/>
-                </a:solidFill>
-                <a:latin typeface="Arial"/>
-              </a:rPr>
-              <a:t>推荐写法</a:t>
-            </a:r>
-          </a:p>
+          <a:noFill/>
+        </p:spPr>
+        <p:txBody>
+          <a:bodyPr wrap="square" lIns="76200" rIns="76200" tIns="50800" bIns="50800">
+            <a:spAutoFit/>
+          </a:bodyPr>
+          <a:lstStyle/>
           <a:p>
             <a:pPr>
-              <a:spcBef>
-                <a:spcPts val="400"/>
-              </a:spcBef>
+              <a:spcAft>
+                <a:spcPts val="800"/>
+              </a:spcAft>
             </a:pPr>
             <a:r>
-              <a:rPr sz="1300" b="0">
+              <a:rPr sz="1800" b="0">
                 <a:solidFill>
                   <a:srgbClr val="1F2937"/>
                 </a:solidFill>
                 <a:latin typeface="Arial"/>
               </a:rPr>
-              <a:t>先不要实现。先快速读关键文件，给我一个可执行计划；只问代码里无法确定的问题。</a:t>
-            </a:r>
-          </a:p>
-        </p:txBody>
-      </p:sp>
-      <p:sp>
-        <p:nvSpPr>
-          <p:cNvPr id="5" name="Rounded Rectangle 4"/>
-          <p:cNvSpPr/>
+              <a:t>独立查询可以显式允许 parallel（并行）</a:t>
+            </a:r>
+          </a:p>
+          <a:p>
+            <a:pPr>
+              <a:spcAft>
+                <a:spcPts val="800"/>
+              </a:spcAft>
+            </a:pPr>
+            <a:r>
+              <a:rPr sz="1800" b="0">
+                <a:solidFill>
+                  <a:srgbClr val="1F2937"/>
+                </a:solidFill>
+                <a:latin typeface="Arial"/>
+              </a:rPr>
+              <a:t>做方案时，先走 Plan Mode 风格：先 Explore，再写计划，再问代码里无法确定的问题</a:t>
+            </a:r>
+          </a:p>
+          <a:p>
+            <a:pPr>
+              <a:spcAft>
+                <a:spcPts val="800"/>
+              </a:spcAft>
+            </a:pPr>
+            <a:r>
+              <a:rPr sz="1800" b="0">
+                <a:solidFill>
+                  <a:srgbClr val="1F2937"/>
+                </a:solidFill>
+                <a:latin typeface="Arial"/>
+              </a:rPr>
+              <a:t>这两条都不是经验贴，而是源码里明确写出来的工作流偏好</a:t>
+            </a:r>
+          </a:p>
+        </p:txBody>
+      </p:sp>
+      <p:sp>
+        <p:nvSpPr>
+          <p:cNvPr id="5" name="TextBox 4"/>
+          <p:cNvSpPr txBox="1"/>
           <p:nvPr/>
         </p:nvSpPr>
         <p:spPr>
           <a:xfrm>
-            <a:off x="4297680" y="1508760"/>
-            <a:ext cx="3474720" cy="1828800"/>
-          </a:xfrm>
-          <a:prstGeom prst="roundRect">
+            <a:off x="841248" y="5532120"/>
+            <a:ext cx="10058400" cy="502920"/>
+          </a:xfrm>
+          <a:prstGeom prst="rect">
             <a:avLst/>
           </a:prstGeom>
-          <a:solidFill>
-            <a:srgbClr val="FFFFFF"/>
-          </a:solidFill>
-          <a:ln>
-            <a:solidFill>
-              <a:srgbClr val="205295"/>
-            </a:solidFill>
-          </a:ln>
-        </p:spPr>
-        <p:style>
-          <a:lnRef idx="1">
-            <a:schemeClr val="accent1"/>
-          </a:lnRef>
-          <a:fillRef idx="3">
-            <a:schemeClr val="accent1"/>
-          </a:fillRef>
-          <a:effectRef idx="2">
-            <a:schemeClr val="accent1"/>
-          </a:effectRef>
-          <a:fontRef idx="minor">
-            <a:schemeClr val="lt1"/>
-          </a:fontRef>
-        </p:style>
-        <p:txBody>
-          <a:bodyPr rtlCol="0" anchor="ctr" wrap="square" lIns="76200" rIns="76200" tIns="50800" bIns="50800"/>
-          <a:lstStyle/>
-          <a:p>
-            <a:pPr algn="ctr"/>
-            <a:r>
-              <a:rPr sz="1600" b="1">
-                <a:solidFill>
-                  <a:srgbClr val="205295"/>
-                </a:solidFill>
-                <a:latin typeface="Arial"/>
-              </a:rPr>
-              <a:t>为什么有效</a:t>
-            </a:r>
-          </a:p>
-          <a:p>
-            <a:pPr>
-              <a:spcBef>
-                <a:spcPts val="400"/>
-              </a:spcBef>
-            </a:pPr>
+          <a:noFill/>
+        </p:spPr>
+        <p:txBody>
+          <a:bodyPr wrap="square" lIns="76200" rIns="76200" tIns="50800" bIns="50800">
+            <a:spAutoFit/>
+          </a:bodyPr>
+          <a:lstStyle/>
+          <a:p>
             <a:r>
               <a:rPr sz="1300" b="0">
                 <a:solidFill>
-                  <a:srgbClr val="1F2937"/>
-                </a:solidFill>
-                <a:latin typeface="Arial"/>
-              </a:rPr>
-              <a:t>Plan Mode 的原生流程就是先 Explore，再写计划，再只问代码解决不了的问题。</a:t>
-            </a:r>
-          </a:p>
-        </p:txBody>
-      </p:sp>
-      <p:sp>
-        <p:nvSpPr>
-          <p:cNvPr id="6" name="Rounded Rectangle 5"/>
-          <p:cNvSpPr/>
-          <p:nvPr/>
-        </p:nvSpPr>
-        <p:spPr>
-          <a:xfrm>
-            <a:off x="8046720" y="1508760"/>
-            <a:ext cx="3383280" cy="1828800"/>
-          </a:xfrm>
-          <a:prstGeom prst="roundRect">
-            <a:avLst/>
-          </a:prstGeom>
-          <a:solidFill>
-            <a:srgbClr val="FFFFFF"/>
-          </a:solidFill>
-          <a:ln>
-            <a:solidFill>
-              <a:srgbClr val="205295"/>
-            </a:solidFill>
-          </a:ln>
-        </p:spPr>
-        <p:style>
-          <a:lnRef idx="1">
-            <a:schemeClr val="accent1"/>
-          </a:lnRef>
-          <a:fillRef idx="3">
-            <a:schemeClr val="accent1"/>
-          </a:fillRef>
-          <a:effectRef idx="2">
-            <a:schemeClr val="accent1"/>
-          </a:effectRef>
-          <a:fontRef idx="minor">
-            <a:schemeClr val="lt1"/>
-          </a:fontRef>
-        </p:style>
-        <p:txBody>
-          <a:bodyPr rtlCol="0" anchor="ctr" wrap="square" lIns="76200" rIns="76200" tIns="50800" bIns="50800"/>
-          <a:lstStyle/>
-          <a:p>
-            <a:pPr algn="ctr"/>
-            <a:r>
-              <a:rPr sz="1600" b="1">
-                <a:solidFill>
-                  <a:srgbClr val="205295"/>
-                </a:solidFill>
-                <a:latin typeface="Arial"/>
-              </a:rPr>
-              <a:t>源码支撑</a:t>
-            </a:r>
-          </a:p>
-          <a:p>
-            <a:pPr>
-              <a:spcBef>
-                <a:spcPts val="400"/>
-              </a:spcBef>
-            </a:pPr>
-            <a:r>
-              <a:rPr sz="1300" b="0">
-                <a:solidFill>
-                  <a:srgbClr val="1F2937"/>
-                </a:solidFill>
-                <a:latin typeface="Arial"/>
-              </a:rPr>
-              <a:t>messages.ts#L3336
-messages.ts#L3350</a:t>
+                  <a:srgbClr val="475569"/>
+                </a:solidFill>
+                <a:latin typeface="Arial"/>
+              </a:rPr>
+              <a:t>源码依据：prompts.ts#L310、messages.ts#L3336、BashTool prompt#L298。</a:t>
             </a:r>
           </a:p>
         </p:txBody>
@@ -3913,7 +3808,7 @@
                 </a:solidFill>
                 <a:latin typeface="Arial"/>
               </a:rPr>
-              <a:t>最后收成 6 条最该记住的注意事项</a:t>
+              <a:t>常见误区与注意事项</a:t>
             </a:r>
           </a:p>
         </p:txBody>
@@ -3995,7 +3890,7 @@
                 </a:solidFill>
                 <a:latin typeface="Arial"/>
               </a:rPr>
-              <a:t>任务写成：目标 + 范围 + 约束 + 验证</a:t>
+              <a:t>不要把 Claude Code 当自由聊天助手来用</a:t>
             </a:r>
           </a:p>
           <a:p>
@@ -4011,7 +3906,7 @@
                 </a:solidFill>
                 <a:latin typeface="Arial"/>
               </a:rPr>
-              <a:t>明确要求先读代码</a:t>
+              <a:t>不要一上来就让它“大改一遍”</a:t>
             </a:r>
           </a:p>
           <a:p>
@@ -4027,7 +3922,7 @@
                 </a:solidFill>
                 <a:latin typeface="Arial"/>
               </a:rPr>
-              <a:t>强调最小改动、优先复用</a:t>
+              <a:t>不要默认它已经验证过</a:t>
             </a:r>
           </a:p>
           <a:p>
@@ -4043,9 +3938,169 @@
                 </a:solidFill>
                 <a:latin typeface="Arial"/>
               </a:rPr>
-              <a:t>优先 dedicated tools，不要默认走 Bash</a:t>
-            </a:r>
-          </a:p>
+              <a:t>不要把高风险授权写得太模糊</a:t>
+            </a:r>
+          </a:p>
+        </p:txBody>
+      </p:sp>
+      <p:sp>
+        <p:nvSpPr>
+          <p:cNvPr id="5" name="TextBox 4"/>
+          <p:cNvSpPr txBox="1"/>
+          <p:nvPr/>
+        </p:nvSpPr>
+        <p:spPr>
+          <a:xfrm>
+            <a:off x="841248" y="5532120"/>
+            <a:ext cx="10058400" cy="502920"/>
+          </a:xfrm>
+          <a:prstGeom prst="rect">
+            <a:avLst/>
+          </a:prstGeom>
+          <a:noFill/>
+        </p:spPr>
+        <p:txBody>
+          <a:bodyPr wrap="square" lIns="76200" rIns="76200" tIns="50800" bIns="50800">
+            <a:spAutoFit/>
+          </a:bodyPr>
+          <a:lstStyle/>
+          <a:p>
+            <a:r>
+              <a:rPr sz="1300" b="0">
+                <a:solidFill>
+                  <a:srgbClr val="475569"/>
+                </a:solidFill>
+                <a:latin typeface="Arial"/>
+              </a:rPr>
+              <a:t>这些误区都能在 prompts.ts 的默认约束里找到根源。</a:t>
+            </a:r>
+          </a:p>
+        </p:txBody>
+      </p:sp>
+    </p:spTree>
+  </p:cSld>
+  <p:clrMapOvr>
+    <a:masterClrMapping/>
+  </p:clrMapOvr>
+</p:sld>
+</file>
+
+<file path=ppt/slides/slide13.xml><?xml version="1.0" encoding="utf-8"?>
+<p:sld xmlns:a="http://schemas.openxmlformats.org/drawingml/2006/main" xmlns:p="http://schemas.openxmlformats.org/presentationml/2006/main" xmlns:r="http://schemas.openxmlformats.org/officeDocument/2006/relationships">
+  <p:cSld>
+    <p:bg>
+      <p:bgPr>
+        <a:solidFill>
+          <a:srgbClr val="F8FAFC"/>
+        </a:solidFill>
+        <a:effectLst/>
+      </p:bgPr>
+    </p:bg>
+    <p:spTree>
+      <p:nvGrpSpPr>
+        <p:cNvPr id="1" name=""/>
+        <p:cNvGrpSpPr/>
+        <p:nvPr/>
+      </p:nvGrpSpPr>
+      <p:grpSpPr/>
+      <p:sp>
+        <p:nvSpPr>
+          <p:cNvPr id="2" name="TextBox 1"/>
+          <p:cNvSpPr txBox="1"/>
+          <p:nvPr/>
+        </p:nvSpPr>
+        <p:spPr>
+          <a:xfrm>
+            <a:off x="594360" y="384048"/>
+            <a:ext cx="10789920" cy="685800"/>
+          </a:xfrm>
+          <a:prstGeom prst="rect">
+            <a:avLst/>
+          </a:prstGeom>
+          <a:noFill/>
+        </p:spPr>
+        <p:txBody>
+          <a:bodyPr wrap="square" lIns="76200" rIns="76200" tIns="50800" bIns="50800">
+            <a:spAutoFit/>
+          </a:bodyPr>
+          <a:lstStyle/>
+          <a:p>
+            <a:r>
+              <a:rPr sz="2600" b="1">
+                <a:solidFill>
+                  <a:srgbClr val="0B1F44"/>
+                </a:solidFill>
+                <a:latin typeface="Arial"/>
+              </a:rPr>
+              <a:t>最后收成 6 条最小使用清单</a:t>
+            </a:r>
+          </a:p>
+        </p:txBody>
+      </p:sp>
+      <p:sp>
+        <p:nvSpPr>
+          <p:cNvPr id="3" name="Rectangle 2"/>
+          <p:cNvSpPr/>
+          <p:nvPr/>
+        </p:nvSpPr>
+        <p:spPr>
+          <a:xfrm>
+            <a:off x="621792" y="1078992"/>
+            <a:ext cx="2011680" cy="27432"/>
+          </a:xfrm>
+          <a:prstGeom prst="rect">
+            <a:avLst/>
+          </a:prstGeom>
+          <a:solidFill>
+            <a:srgbClr val="DBE4F0"/>
+          </a:solidFill>
+          <a:ln>
+            <a:noFill/>
+          </a:ln>
+        </p:spPr>
+        <p:style>
+          <a:lnRef idx="1">
+            <a:schemeClr val="accent1"/>
+          </a:lnRef>
+          <a:fillRef idx="3">
+            <a:schemeClr val="accent1"/>
+          </a:fillRef>
+          <a:effectRef idx="2">
+            <a:schemeClr val="accent1"/>
+          </a:effectRef>
+          <a:fontRef idx="minor">
+            <a:schemeClr val="lt1"/>
+          </a:fontRef>
+        </p:style>
+        <p:txBody>
+          <a:bodyPr rtlCol="0" anchor="ctr"/>
+          <a:lstStyle/>
+          <a:p>
+            <a:pPr algn="ctr"/>
+          </a:p>
+        </p:txBody>
+      </p:sp>
+      <p:sp>
+        <p:nvSpPr>
+          <p:cNvPr id="4" name="TextBox 3"/>
+          <p:cNvSpPr txBox="1"/>
+          <p:nvPr/>
+        </p:nvSpPr>
+        <p:spPr>
+          <a:xfrm>
+            <a:off x="777240" y="1508760"/>
+            <a:ext cx="10241280" cy="4389120"/>
+          </a:xfrm>
+          <a:prstGeom prst="rect">
+            <a:avLst/>
+          </a:prstGeom>
+          <a:noFill/>
+        </p:spPr>
+        <p:txBody>
+          <a:bodyPr wrap="square" lIns="76200" rIns="76200" tIns="50800" bIns="50800">
+            <a:spAutoFit/>
+          </a:bodyPr>
+          <a:lstStyle/>
           <a:p>
             <a:pPr>
               <a:spcAft>
@@ -4059,7 +4114,7 @@
                 </a:solidFill>
                 <a:latin typeface="Arial"/>
               </a:rPr>
-              <a:t>验证结果要如实汇报</a:t>
+              <a:t>任务写成：目标 + 范围 + 约束 + 验证</a:t>
             </a:r>
           </a:p>
           <a:p>
@@ -4075,6 +4130,70 @@
                 </a:solidFill>
                 <a:latin typeface="Arial"/>
               </a:rPr>
+              <a:t>明确要求先读代码</a:t>
+            </a:r>
+          </a:p>
+          <a:p>
+            <a:pPr>
+              <a:spcAft>
+                <a:spcPts val="800"/>
+              </a:spcAft>
+            </a:pPr>
+            <a:r>
+              <a:rPr sz="1800" b="0">
+                <a:solidFill>
+                  <a:srgbClr val="1F2937"/>
+                </a:solidFill>
+                <a:latin typeface="Arial"/>
+              </a:rPr>
+              <a:t>强调最小改动、优先复用</a:t>
+            </a:r>
+          </a:p>
+          <a:p>
+            <a:pPr>
+              <a:spcAft>
+                <a:spcPts val="800"/>
+              </a:spcAft>
+            </a:pPr>
+            <a:r>
+              <a:rPr sz="1800" b="0">
+                <a:solidFill>
+                  <a:srgbClr val="1F2937"/>
+                </a:solidFill>
+                <a:latin typeface="Arial"/>
+              </a:rPr>
+              <a:t>优先 dedicated tools，不要默认走 Bash</a:t>
+            </a:r>
+          </a:p>
+          <a:p>
+            <a:pPr>
+              <a:spcAft>
+                <a:spcPts val="800"/>
+              </a:spcAft>
+            </a:pPr>
+            <a:r>
+              <a:rPr sz="1800" b="0">
+                <a:solidFill>
+                  <a:srgbClr val="1F2937"/>
+                </a:solidFill>
+                <a:latin typeface="Arial"/>
+              </a:rPr>
+              <a:t>验证结果要如实汇报</a:t>
+            </a:r>
+          </a:p>
+          <a:p>
+            <a:pPr>
+              <a:spcAft>
+                <a:spcPts val="800"/>
+              </a:spcAft>
+            </a:pPr>
+            <a:r>
+              <a:rPr sz="1800" b="0">
+                <a:solidFill>
+                  <a:srgbClr val="1F2937"/>
+                </a:solidFill>
+                <a:latin typeface="Arial"/>
+              </a:rPr>
               <a:t>高风险动作先确认</a:t>
             </a:r>
           </a:p>
@@ -4109,7 +4228,7 @@
                 </a:solidFill>
                 <a:latin typeface="Arial"/>
               </a:rPr>
-              <a:t>这些建议不是经验口号，而是能直接在源码 prompt 和执行约束里找到依据。</a:t>
+              <a:t>这些建议的共同点是：让用户输入尽量贴近 Claude Code 源码里的默认工作方式。</a:t>
             </a:r>
           </a:p>
         </p:txBody>
@@ -4169,7 +4288,7 @@
                 </a:solidFill>
                 <a:latin typeface="Arial"/>
               </a:rPr>
-              <a:t>先给结论</a:t>
+              <a:t>先给结论：Claude Code 不是什么</a:t>
             </a:r>
           </a:p>
         </p:txBody>
@@ -4251,7 +4370,7 @@
                 </a:solidFill>
                 <a:latin typeface="Arial"/>
               </a:rPr>
-              <a:t>Claude Code 默认把用户请求理解成软件工程任务，不是自由聊天</a:t>
+              <a:t>它不是自由聊天助手，也不是“随便说一句就稳定帮你把工程活干好”的黑盒</a:t>
             </a:r>
           </a:p>
           <a:p>
@@ -4267,7 +4386,7 @@
                 </a:solidFill>
                 <a:latin typeface="Arial"/>
               </a:rPr>
-              <a:t>它偏好：先读代码、最小改动、优先复用、专用工具优先、验证后如实汇报</a:t>
+              <a:t>从源码看，它更像 software engineering agent（软件工程代理）</a:t>
             </a:r>
           </a:p>
           <a:p>
@@ -4283,7 +4402,7 @@
                 </a:solidFill>
                 <a:latin typeface="Arial"/>
               </a:rPr>
-              <a:t>所以用户提示词越工程化，它的表现越稳定</a:t>
+              <a:t>所以用户输入越工程化，Claude Code 的表现通常越稳定</a:t>
             </a:r>
           </a:p>
         </p:txBody>
@@ -4317,7 +4436,7 @@
                 </a:solidFill>
                 <a:latin typeface="Arial"/>
               </a:rPr>
-              <a:t>核心依据主要来自 prompts.ts、messages.ts 和 BashTool prompt。</a:t>
+              <a:t>源码依据：prompts.ts 把默认场景定义为 software engineering task。</a:t>
             </a:r>
           </a:p>
         </p:txBody>
@@ -4377,7 +4496,7 @@
                 </a:solidFill>
                 <a:latin typeface="Arial"/>
               </a:rPr>
-              <a:t>技巧 1：任务写成“目标 + 范围 + 约束 + 验证”</a:t>
+              <a:t>从源码看：Claude Code 是什么</a:t>
             </a:r>
           </a:p>
         </p:txBody>
@@ -4427,215 +4546,137 @@
       </p:sp>
       <p:sp>
         <p:nvSpPr>
-          <p:cNvPr id="4" name="Rounded Rectangle 3"/>
-          <p:cNvSpPr/>
+          <p:cNvPr id="4" name="TextBox 3"/>
+          <p:cNvSpPr txBox="1"/>
           <p:nvPr/>
         </p:nvSpPr>
         <p:spPr>
           <a:xfrm>
-            <a:off x="731520" y="1508760"/>
-            <a:ext cx="3291840" cy="1828800"/>
-          </a:xfrm>
-          <a:prstGeom prst="roundRect">
+            <a:off x="777240" y="1508760"/>
+            <a:ext cx="10241280" cy="4389120"/>
+          </a:xfrm>
+          <a:prstGeom prst="rect">
             <a:avLst/>
           </a:prstGeom>
-          <a:solidFill>
-            <a:srgbClr val="FFFFFF"/>
-          </a:solidFill>
-          <a:ln>
-            <a:solidFill>
-              <a:srgbClr val="205295"/>
-            </a:solidFill>
-          </a:ln>
-        </p:spPr>
-        <p:style>
-          <a:lnRef idx="1">
-            <a:schemeClr val="accent1"/>
-          </a:lnRef>
-          <a:fillRef idx="3">
-            <a:schemeClr val="accent1"/>
-          </a:fillRef>
-          <a:effectRef idx="2">
-            <a:schemeClr val="accent1"/>
-          </a:effectRef>
-          <a:fontRef idx="minor">
-            <a:schemeClr val="lt1"/>
-          </a:fontRef>
-        </p:style>
-        <p:txBody>
-          <a:bodyPr rtlCol="0" anchor="ctr" wrap="square" lIns="76200" rIns="76200" tIns="50800" bIns="50800"/>
-          <a:lstStyle/>
-          <a:p>
-            <a:pPr algn="ctr"/>
-            <a:r>
-              <a:rPr sz="1600" b="1">
-                <a:solidFill>
-                  <a:srgbClr val="205295"/>
-                </a:solidFill>
-                <a:latin typeface="Arial"/>
-              </a:rPr>
-              <a:t>推荐写法</a:t>
-            </a:r>
-          </a:p>
+          <a:noFill/>
+        </p:spPr>
+        <p:txBody>
+          <a:bodyPr wrap="square" lIns="76200" rIns="76200" tIns="50800" bIns="50800">
+            <a:spAutoFit/>
+          </a:bodyPr>
+          <a:lstStyle/>
           <a:p>
             <a:pPr>
-              <a:spcBef>
-                <a:spcPts val="400"/>
-              </a:spcBef>
+              <a:spcAft>
+                <a:spcPts val="800"/>
+              </a:spcAft>
             </a:pPr>
             <a:r>
-              <a:rPr sz="1300" b="0">
+              <a:rPr sz="1800" b="0">
                 <a:solidFill>
                   <a:srgbClr val="1F2937"/>
                 </a:solidFill>
                 <a:latin typeface="Arial"/>
               </a:rPr>
-              <a:t>目标：修复/实现……
-范围：只改……
-约束：不要做无关重构
-验证：跑测试并说明结果</a:t>
-            </a:r>
-          </a:p>
-        </p:txBody>
-      </p:sp>
-      <p:sp>
-        <p:nvSpPr>
-          <p:cNvPr id="5" name="Rounded Rectangle 4"/>
-          <p:cNvSpPr/>
+              <a:t>main.tsx：bootstrap / assembly（启动装配）</a:t>
+            </a:r>
+          </a:p>
+          <a:p>
+            <a:pPr>
+              <a:spcAft>
+                <a:spcPts val="800"/>
+              </a:spcAft>
+            </a:pPr>
+            <a:r>
+              <a:rPr sz="1800" b="0">
+                <a:solidFill>
+                  <a:srgbClr val="1F2937"/>
+                </a:solidFill>
+                <a:latin typeface="Arial"/>
+              </a:rPr>
+              <a:t>QueryEngine.ts：conversation host（会话宿主）</a:t>
+            </a:r>
+          </a:p>
+          <a:p>
+            <a:pPr>
+              <a:spcAft>
+                <a:spcPts val="800"/>
+              </a:spcAft>
+            </a:pPr>
+            <a:r>
+              <a:rPr sz="1800" b="0">
+                <a:solidFill>
+                  <a:srgbClr val="1F2937"/>
+                </a:solidFill>
+                <a:latin typeface="Arial"/>
+              </a:rPr>
+              <a:t>query.ts：turn loop / runtime kernel（轮次循环 / 运行时内核）</a:t>
+            </a:r>
+          </a:p>
+          <a:p>
+            <a:pPr>
+              <a:spcAft>
+                <a:spcPts val="800"/>
+              </a:spcAft>
+            </a:pPr>
+            <a:r>
+              <a:rPr sz="1800" b="0">
+                <a:solidFill>
+                  <a:srgbClr val="1F2937"/>
+                </a:solidFill>
+                <a:latin typeface="Arial"/>
+              </a:rPr>
+              <a:t>toolExecution.ts：tool pipeline（工具执行流水线）</a:t>
+            </a:r>
+          </a:p>
+          <a:p>
+            <a:pPr>
+              <a:spcAft>
+                <a:spcPts val="800"/>
+              </a:spcAft>
+            </a:pPr>
+            <a:r>
+              <a:rPr sz="1800" b="0">
+                <a:solidFill>
+                  <a:srgbClr val="1F2937"/>
+                </a:solidFill>
+                <a:latin typeface="Arial"/>
+              </a:rPr>
+              <a:t>settings / auth / prompt / policy：control plane（控制面）</a:t>
+            </a:r>
+          </a:p>
+        </p:txBody>
+      </p:sp>
+      <p:sp>
+        <p:nvSpPr>
+          <p:cNvPr id="5" name="TextBox 4"/>
+          <p:cNvSpPr txBox="1"/>
           <p:nvPr/>
         </p:nvSpPr>
         <p:spPr>
           <a:xfrm>
-            <a:off x="4297680" y="1508760"/>
-            <a:ext cx="3474720" cy="1828800"/>
-          </a:xfrm>
-          <a:prstGeom prst="roundRect">
+            <a:off x="841248" y="5532120"/>
+            <a:ext cx="10058400" cy="502920"/>
+          </a:xfrm>
+          <a:prstGeom prst="rect">
             <a:avLst/>
           </a:prstGeom>
-          <a:solidFill>
-            <a:srgbClr val="FFFFFF"/>
-          </a:solidFill>
-          <a:ln>
-            <a:solidFill>
-              <a:srgbClr val="205295"/>
-            </a:solidFill>
-          </a:ln>
-        </p:spPr>
-        <p:style>
-          <a:lnRef idx="1">
-            <a:schemeClr val="accent1"/>
-          </a:lnRef>
-          <a:fillRef idx="3">
-            <a:schemeClr val="accent1"/>
-          </a:fillRef>
-          <a:effectRef idx="2">
-            <a:schemeClr val="accent1"/>
-          </a:effectRef>
-          <a:fontRef idx="minor">
-            <a:schemeClr val="lt1"/>
-          </a:fontRef>
-        </p:style>
-        <p:txBody>
-          <a:bodyPr rtlCol="0" anchor="ctr" wrap="square" lIns="76200" rIns="76200" tIns="50800" bIns="50800"/>
-          <a:lstStyle/>
-          <a:p>
-            <a:pPr algn="ctr"/>
-            <a:r>
-              <a:rPr sz="1600" b="1">
-                <a:solidFill>
-                  <a:srgbClr val="205295"/>
-                </a:solidFill>
-                <a:latin typeface="Arial"/>
-              </a:rPr>
-              <a:t>为什么有效</a:t>
-            </a:r>
-          </a:p>
-          <a:p>
-            <a:pPr>
-              <a:spcBef>
-                <a:spcPts val="400"/>
-              </a:spcBef>
-            </a:pPr>
+          <a:noFill/>
+        </p:spPr>
+        <p:txBody>
+          <a:bodyPr wrap="square" lIns="76200" rIns="76200" tIns="50800" bIns="50800">
+            <a:spAutoFit/>
+          </a:bodyPr>
+          <a:lstStyle/>
+          <a:p>
             <a:r>
               <a:rPr sz="1300" b="0">
                 <a:solidFill>
-                  <a:srgbClr val="1F2937"/>
-                </a:solidFill>
-                <a:latin typeface="Arial"/>
-              </a:rPr>
-              <a:t>源码把默认场景设成软件工程任务；明确范围和验证能减少分析/实现/顺手优化之间的歧义。</a:t>
-            </a:r>
-          </a:p>
-        </p:txBody>
-      </p:sp>
-      <p:sp>
-        <p:nvSpPr>
-          <p:cNvPr id="6" name="Rounded Rectangle 5"/>
-          <p:cNvSpPr/>
-          <p:nvPr/>
-        </p:nvSpPr>
-        <p:spPr>
-          <a:xfrm>
-            <a:off x="8046720" y="1508760"/>
-            <a:ext cx="3383280" cy="1828800"/>
-          </a:xfrm>
-          <a:prstGeom prst="roundRect">
-            <a:avLst/>
-          </a:prstGeom>
-          <a:solidFill>
-            <a:srgbClr val="FFFFFF"/>
-          </a:solidFill>
-          <a:ln>
-            <a:solidFill>
-              <a:srgbClr val="205295"/>
-            </a:solidFill>
-          </a:ln>
-        </p:spPr>
-        <p:style>
-          <a:lnRef idx="1">
-            <a:schemeClr val="accent1"/>
-          </a:lnRef>
-          <a:fillRef idx="3">
-            <a:schemeClr val="accent1"/>
-          </a:fillRef>
-          <a:effectRef idx="2">
-            <a:schemeClr val="accent1"/>
-          </a:effectRef>
-          <a:fontRef idx="minor">
-            <a:schemeClr val="lt1"/>
-          </a:fontRef>
-        </p:style>
-        <p:txBody>
-          <a:bodyPr rtlCol="0" anchor="ctr" wrap="square" lIns="76200" rIns="76200" tIns="50800" bIns="50800"/>
-          <a:lstStyle/>
-          <a:p>
-            <a:pPr algn="ctr"/>
-            <a:r>
-              <a:rPr sz="1600" b="1">
-                <a:solidFill>
-                  <a:srgbClr val="205295"/>
-                </a:solidFill>
-                <a:latin typeface="Arial"/>
-              </a:rPr>
-              <a:t>源码支撑</a:t>
-            </a:r>
-          </a:p>
-          <a:p>
-            <a:pPr>
-              <a:spcBef>
-                <a:spcPts val="400"/>
-              </a:spcBef>
-            </a:pPr>
-            <a:r>
-              <a:rPr sz="1300" b="0">
-                <a:solidFill>
-                  <a:srgbClr val="1F2937"/>
-                </a:solidFill>
-                <a:latin typeface="Arial"/>
-              </a:rPr>
-              <a:t>prompts.ts#L221
-prompts.ts#L230
-prompts.ts#L240</a:t>
+                  <a:srgbClr val="475569"/>
+                </a:solidFill>
+                <a:latin typeface="Arial"/>
+              </a:rPr>
+              <a:t>这决定了它默认不是把输入当闲聊，而是当软件工程任务。</a:t>
             </a:r>
           </a:p>
         </p:txBody>
@@ -4695,7 +4736,7 @@
                 </a:solidFill>
                 <a:latin typeface="Arial"/>
               </a:rPr>
-              <a:t>技巧 2：明确要求先读代码，再改代码</a:t>
+              <a:t>从源码反推：默认偏好的工作方式</a:t>
             </a:r>
           </a:p>
         </p:txBody>
@@ -4745,211 +4786,137 @@
       </p:sp>
       <p:sp>
         <p:nvSpPr>
-          <p:cNvPr id="4" name="Rounded Rectangle 3"/>
-          <p:cNvSpPr/>
+          <p:cNvPr id="4" name="TextBox 3"/>
+          <p:cNvSpPr txBox="1"/>
           <p:nvPr/>
         </p:nvSpPr>
         <p:spPr>
           <a:xfrm>
-            <a:off x="731520" y="1508760"/>
-            <a:ext cx="3291840" cy="1828800"/>
-          </a:xfrm>
-          <a:prstGeom prst="roundRect">
+            <a:off x="777240" y="1508760"/>
+            <a:ext cx="10241280" cy="4389120"/>
+          </a:xfrm>
+          <a:prstGeom prst="rect">
             <a:avLst/>
           </a:prstGeom>
-          <a:solidFill>
-            <a:srgbClr val="FFFFFF"/>
-          </a:solidFill>
-          <a:ln>
-            <a:solidFill>
-              <a:srgbClr val="205295"/>
-            </a:solidFill>
-          </a:ln>
-        </p:spPr>
-        <p:style>
-          <a:lnRef idx="1">
-            <a:schemeClr val="accent1"/>
-          </a:lnRef>
-          <a:fillRef idx="3">
-            <a:schemeClr val="accent1"/>
-          </a:fillRef>
-          <a:effectRef idx="2">
-            <a:schemeClr val="accent1"/>
-          </a:effectRef>
-          <a:fontRef idx="minor">
-            <a:schemeClr val="lt1"/>
-          </a:fontRef>
-        </p:style>
-        <p:txBody>
-          <a:bodyPr rtlCol="0" anchor="ctr" wrap="square" lIns="76200" rIns="76200" tIns="50800" bIns="50800"/>
-          <a:lstStyle/>
-          <a:p>
-            <a:pPr algn="ctr"/>
-            <a:r>
-              <a:rPr sz="1600" b="1">
-                <a:solidFill>
-                  <a:srgbClr val="205295"/>
-                </a:solidFill>
-                <a:latin typeface="Arial"/>
-              </a:rPr>
-              <a:t>推荐写法</a:t>
-            </a:r>
-          </a:p>
+          <a:noFill/>
+        </p:spPr>
+        <p:txBody>
+          <a:bodyPr wrap="square" lIns="76200" rIns="76200" tIns="50800" bIns="50800">
+            <a:spAutoFit/>
+          </a:bodyPr>
+          <a:lstStyle/>
           <a:p>
             <a:pPr>
-              <a:spcBef>
-                <a:spcPts val="400"/>
-              </a:spcBef>
+              <a:spcAft>
+                <a:spcPts val="800"/>
+              </a:spcAft>
             </a:pPr>
             <a:r>
-              <a:rPr sz="1300" b="0">
+              <a:rPr sz="1800" b="0">
                 <a:solidFill>
                   <a:srgbClr val="1F2937"/>
                 </a:solidFill>
                 <a:latin typeface="Arial"/>
               </a:rPr>
-              <a:t>先看 src/foo.ts 和 src/bar.ts，再决定改法。</a:t>
-            </a:r>
-          </a:p>
-        </p:txBody>
-      </p:sp>
-      <p:sp>
-        <p:nvSpPr>
-          <p:cNvPr id="5" name="Rounded Rectangle 4"/>
-          <p:cNvSpPr/>
+              <a:t>先读代码，再改代码</a:t>
+            </a:r>
+          </a:p>
+          <a:p>
+            <a:pPr>
+              <a:spcAft>
+                <a:spcPts val="800"/>
+              </a:spcAft>
+            </a:pPr>
+            <a:r>
+              <a:rPr sz="1800" b="0">
+                <a:solidFill>
+                  <a:srgbClr val="1F2937"/>
+                </a:solidFill>
+                <a:latin typeface="Arial"/>
+              </a:rPr>
+              <a:t>最小必要改动，优先复用已有实现</a:t>
+            </a:r>
+          </a:p>
+          <a:p>
+            <a:pPr>
+              <a:spcAft>
+                <a:spcPts val="800"/>
+              </a:spcAft>
+            </a:pPr>
+            <a:r>
+              <a:rPr sz="1800" b="0">
+                <a:solidFill>
+                  <a:srgbClr val="1F2937"/>
+                </a:solidFill>
+                <a:latin typeface="Arial"/>
+              </a:rPr>
+              <a:t>优先 dedicated tools，而不是默认 Bash</a:t>
+            </a:r>
+          </a:p>
+          <a:p>
+            <a:pPr>
+              <a:spcAft>
+                <a:spcPts val="800"/>
+              </a:spcAft>
+            </a:pPr>
+            <a:r>
+              <a:rPr sz="1800" b="0">
+                <a:solidFill>
+                  <a:srgbClr val="1F2937"/>
+                </a:solidFill>
+                <a:latin typeface="Arial"/>
+              </a:rPr>
+              <a:t>验证后如实汇报</a:t>
+            </a:r>
+          </a:p>
+          <a:p>
+            <a:pPr>
+              <a:spcAft>
+                <a:spcPts val="800"/>
+              </a:spcAft>
+            </a:pPr>
+            <a:r>
+              <a:rPr sz="1800" b="0">
+                <a:solidFill>
+                  <a:srgbClr val="1F2937"/>
+                </a:solidFill>
+                <a:latin typeface="Arial"/>
+              </a:rPr>
+              <a:t>高风险动作默认先确认</a:t>
+            </a:r>
+          </a:p>
+        </p:txBody>
+      </p:sp>
+      <p:sp>
+        <p:nvSpPr>
+          <p:cNvPr id="5" name="TextBox 4"/>
+          <p:cNvSpPr txBox="1"/>
           <p:nvPr/>
         </p:nvSpPr>
         <p:spPr>
           <a:xfrm>
-            <a:off x="4297680" y="1508760"/>
-            <a:ext cx="3474720" cy="1828800"/>
-          </a:xfrm>
-          <a:prstGeom prst="roundRect">
+            <a:off x="841248" y="5532120"/>
+            <a:ext cx="10058400" cy="502920"/>
+          </a:xfrm>
+          <a:prstGeom prst="rect">
             <a:avLst/>
           </a:prstGeom>
-          <a:solidFill>
-            <a:srgbClr val="FFFFFF"/>
-          </a:solidFill>
-          <a:ln>
-            <a:solidFill>
-              <a:srgbClr val="205295"/>
-            </a:solidFill>
-          </a:ln>
-        </p:spPr>
-        <p:style>
-          <a:lnRef idx="1">
-            <a:schemeClr val="accent1"/>
-          </a:lnRef>
-          <a:fillRef idx="3">
-            <a:schemeClr val="accent1"/>
-          </a:fillRef>
-          <a:effectRef idx="2">
-            <a:schemeClr val="accent1"/>
-          </a:effectRef>
-          <a:fontRef idx="minor">
-            <a:schemeClr val="lt1"/>
-          </a:fontRef>
-        </p:style>
-        <p:txBody>
-          <a:bodyPr rtlCol="0" anchor="ctr" wrap="square" lIns="76200" rIns="76200" tIns="50800" bIns="50800"/>
-          <a:lstStyle/>
-          <a:p>
-            <a:pPr algn="ctr"/>
-            <a:r>
-              <a:rPr sz="1600" b="1">
-                <a:solidFill>
-                  <a:srgbClr val="205295"/>
-                </a:solidFill>
-                <a:latin typeface="Arial"/>
-              </a:rPr>
-              <a:t>为什么有效</a:t>
-            </a:r>
-          </a:p>
-          <a:p>
-            <a:pPr>
-              <a:spcBef>
-                <a:spcPts val="400"/>
-              </a:spcBef>
-            </a:pPr>
+          <a:noFill/>
+        </p:spPr>
+        <p:txBody>
+          <a:bodyPr wrap="square" lIns="76200" rIns="76200" tIns="50800" bIns="50800">
+            <a:spAutoFit/>
+          </a:bodyPr>
+          <a:lstStyle/>
+          <a:p>
             <a:r>
               <a:rPr sz="1300" b="0">
                 <a:solidFill>
-                  <a:srgbClr val="1F2937"/>
-                </a:solidFill>
-                <a:latin typeface="Arial"/>
-              </a:rPr>
-              <a:t>系统提示明确偏好先理解现有实现；点名关键文件能减少无关探索和上下文噪音。</a:t>
-            </a:r>
-          </a:p>
-        </p:txBody>
-      </p:sp>
-      <p:sp>
-        <p:nvSpPr>
-          <p:cNvPr id="6" name="Rounded Rectangle 5"/>
-          <p:cNvSpPr/>
-          <p:nvPr/>
-        </p:nvSpPr>
-        <p:spPr>
-          <a:xfrm>
-            <a:off x="8046720" y="1508760"/>
-            <a:ext cx="3383280" cy="1828800"/>
-          </a:xfrm>
-          <a:prstGeom prst="roundRect">
-            <a:avLst/>
-          </a:prstGeom>
-          <a:solidFill>
-            <a:srgbClr val="FFFFFF"/>
-          </a:solidFill>
-          <a:ln>
-            <a:solidFill>
-              <a:srgbClr val="205295"/>
-            </a:solidFill>
-          </a:ln>
-        </p:spPr>
-        <p:style>
-          <a:lnRef idx="1">
-            <a:schemeClr val="accent1"/>
-          </a:lnRef>
-          <a:fillRef idx="3">
-            <a:schemeClr val="accent1"/>
-          </a:fillRef>
-          <a:effectRef idx="2">
-            <a:schemeClr val="accent1"/>
-          </a:effectRef>
-          <a:fontRef idx="minor">
-            <a:schemeClr val="lt1"/>
-          </a:fontRef>
-        </p:style>
-        <p:txBody>
-          <a:bodyPr rtlCol="0" anchor="ctr" wrap="square" lIns="76200" rIns="76200" tIns="50800" bIns="50800"/>
-          <a:lstStyle/>
-          <a:p>
-            <a:pPr algn="ctr"/>
-            <a:r>
-              <a:rPr sz="1600" b="1">
-                <a:solidFill>
-                  <a:srgbClr val="205295"/>
-                </a:solidFill>
-                <a:latin typeface="Arial"/>
-              </a:rPr>
-              <a:t>源码支撑</a:t>
-            </a:r>
-          </a:p>
-          <a:p>
-            <a:pPr>
-              <a:spcBef>
-                <a:spcPts val="400"/>
-              </a:spcBef>
-            </a:pPr>
-            <a:r>
-              <a:rPr sz="1300" b="0">
-                <a:solidFill>
-                  <a:srgbClr val="1F2937"/>
-                </a:solidFill>
-                <a:latin typeface="Arial"/>
-              </a:rPr>
-              <a:t>prompts.ts#L230
-messages.ts#L3344</a:t>
+                  <a:srgbClr val="475569"/>
+                </a:solidFill>
+                <a:latin typeface="Arial"/>
+              </a:rPr>
+              <a:t>这些偏好主要来自 prompts.ts、messages.ts 和 BashTool prompt。</a:t>
             </a:r>
           </a:p>
         </p:txBody>
@@ -5009,7 +4976,7 @@
                 </a:solidFill>
                 <a:latin typeface="Arial"/>
               </a:rPr>
-              <a:t>技巧 3：强调最小改动、优先复用</a:t>
+              <a:t>技巧 1：任务写成“目标 + 范围 + 约束 + 验证”</a:t>
             </a:r>
           </a:p>
         </p:txBody>
@@ -5122,7 +5089,10 @@
                 </a:solidFill>
                 <a:latin typeface="Arial"/>
               </a:rPr>
-              <a:t>做最小必要改动；优先复用现有函数、工具和模式；不要新造一层抽象。</a:t>
+              <a:t>目标：修复/实现……
+范围：只改……
+约束：不要做无关重构
+验证：跑测试并说明结果</a:t>
             </a:r>
           </a:p>
         </p:txBody>
@@ -5192,7 +5162,7 @@
                 </a:solidFill>
                 <a:latin typeface="Arial"/>
               </a:rPr>
-              <a:t>源码明确反对 one-time helper 和 premature abstraction；这样更容易顺着现有结构修改。</a:t>
+              <a:t>源码把默认场景设成 software engineering task；明确范围和验证能减少分析/实现/顺手优化之间的歧义。</a:t>
             </a:r>
           </a:p>
         </p:txBody>
@@ -5262,9 +5232,9 @@
                 </a:solidFill>
                 <a:latin typeface="Arial"/>
               </a:rPr>
-              <a:t>prompts.ts#L200
-prompts.ts#L203
-messages.ts#L3344</a:t>
+              <a:t>prompts.ts#L221
+prompts.ts#L230
+prompts.ts#L240</a:t>
             </a:r>
           </a:p>
         </p:txBody>
@@ -5324,7 +5294,7 @@
                 </a:solidFill>
                 <a:latin typeface="Arial"/>
               </a:rPr>
-              <a:t>技巧 4：能不新建文件，就不要新建文件</a:t>
+              <a:t>技巧 2：明确要求先读代码，再改代码</a:t>
             </a:r>
           </a:p>
         </p:txBody>
@@ -5437,7 +5407,7 @@
                 </a:solidFill>
                 <a:latin typeface="Arial"/>
               </a:rPr>
-              <a:t>除非绝对必要，不要新建文件，优先修改现有文件。</a:t>
+              <a:t>先看 src/foo.ts 和 src/bar.ts，再决定改法。</a:t>
             </a:r>
           </a:p>
         </p:txBody>
@@ -5507,7 +5477,7 @@
                 </a:solidFill>
                 <a:latin typeface="Arial"/>
               </a:rPr>
-              <a:t>系统把避免 file bloat 设为默认偏好；对小改动尤其能防止多余 helper / temp file。</a:t>
+              <a:t>系统提示明确偏好先理解现有实现；点名关键文件能减少无关探索和上下文噪音。</a:t>
             </a:r>
           </a:p>
         </p:txBody>
@@ -5577,7 +5547,8 @@
                 </a:solidFill>
                 <a:latin typeface="Arial"/>
               </a:rPr>
-              <a:t>prompts.ts#L231</a:t>
+              <a:t>prompts.ts#L230
+messages.ts#L3344</a:t>
             </a:r>
           </a:p>
         </p:txBody>
@@ -5637,7 +5608,7 @@
                 </a:solidFill>
                 <a:latin typeface="Arial"/>
               </a:rPr>
-              <a:t>技巧 5：优先 dedicated tools，不要滥用 Bash</a:t>
+              <a:t>技巧 3：强调最小改动、优先复用</a:t>
             </a:r>
           </a:p>
         </p:txBody>
@@ -5750,7 +5721,7 @@
                 </a:solidFill>
                 <a:latin typeface="Arial"/>
               </a:rPr>
-              <a:t>优先直接读写文件，不要用 Bash 做本可由专用工具完成的事情。</a:t>
+              <a:t>做最小必要改动；优先复用现有函数、工具和模式；不要新造一层抽象。</a:t>
             </a:r>
           </a:p>
         </p:txBody>
@@ -5820,7 +5791,7 @@
                 </a:solidFill>
                 <a:latin typeface="Arial"/>
               </a:rPr>
-              <a:t>Bash 在源码里是 fallback tool，不是首选；专用工具更容易被审查、解释和权限约束。</a:t>
+              <a:t>源码明确反对 one-time helper 和 premature abstraction；这样更容易顺着现有结构修改。</a:t>
             </a:r>
           </a:p>
         </p:txBody>
@@ -5890,9 +5861,9 @@
                 </a:solidFill>
                 <a:latin typeface="Arial"/>
               </a:rPr>
-              <a:t>prompts.ts#L301
-prompts.ts#L305
-BashTool prompt#L297</a:t>
+              <a:t>prompts.ts#L200
+prompts.ts#L203
+messages.ts#L3344</a:t>
             </a:r>
           </a:p>
         </p:txBody>
@@ -5952,7 +5923,7 @@
                 </a:solidFill>
                 <a:latin typeface="Arial"/>
               </a:rPr>
-              <a:t>技巧 6：验证要求要写清楚，而且要如实汇报</a:t>
+              <a:t>技巧 4：优先 dedicated tools，不要默认 Bash</a:t>
             </a:r>
           </a:p>
         </p:txBody>
@@ -6065,7 +6036,7 @@
                 </a:solidFill>
                 <a:latin typeface="Arial"/>
               </a:rPr>
-              <a:t>改完后跑相关测试；如果没跑，请明确说明没有跑。</a:t>
+              <a:t>优先直接读写文件，不要用 Bash 做本可由专用工具完成的事情。</a:t>
             </a:r>
           </a:p>
         </p:txBody>
@@ -6135,7 +6106,7 @@
                 </a:solidFill>
                 <a:latin typeface="Arial"/>
               </a:rPr>
-              <a:t>源码对“未验证却宣称完成”是强约束；这样能减少看似完成、其实没验证的风险。</a:t>
+              <a:t>Bash 在源码里是 fallback tool，不是首选；专用工具更容易被审查、解释和权限约束。</a:t>
             </a:r>
           </a:p>
         </p:txBody>
@@ -6205,8 +6176,9 @@
                 </a:solidFill>
                 <a:latin typeface="Arial"/>
               </a:rPr>
-              <a:t>prompts.ts#L211
-prompts.ts#L240</a:t>
+              <a:t>prompts.ts#L301
+prompts.ts#L305
+BashTool prompt#L297</a:t>
             </a:r>
           </a:p>
         </p:txBody>
@@ -6266,7 +6238,7 @@
                 </a:solidFill>
                 <a:latin typeface="Arial"/>
               </a:rPr>
-              <a:t>技巧 7：独立查询要显式允许 parallel</a:t>
+              <a:t>技巧 5：验证要求要写清楚，而且要如实汇报</a:t>
             </a:r>
           </a:p>
         </p:txBody>
@@ -6379,7 +6351,7 @@
                 </a:solidFill>
                 <a:latin typeface="Arial"/>
               </a:rPr>
-              <a:t>如果这些查询彼此独立，可以并行完成；不要重复做相同搜索。</a:t>
+              <a:t>改完后跑相关测试；如果没跑，请明确说明没有跑。</a:t>
             </a:r>
           </a:p>
         </p:txBody>
@@ -6449,7 +6421,7 @@
                 </a:solidFill>
                 <a:latin typeface="Arial"/>
               </a:rPr>
-              <a:t>系统提示明确鼓励独立工具调用并行化；Bash prompt 和 Plan Mode 也都强调能并行就并行。</a:t>
+              <a:t>源码对“未验证却宣称完成”是强约束；这样能减少看似完成、其实没验证的风险。</a:t>
             </a:r>
           </a:p>
         </p:txBody>
@@ -6519,9 +6491,8 @@
                 </a:solidFill>
                 <a:latin typeface="Arial"/>
               </a:rPr>
-              <a:t>prompts.ts#L310
-prompts.ts#L319
-messages.ts#L3344</a:t>
+              <a:t>prompts.ts#L211
+prompts.ts#L240</a:t>
             </a:r>
           </a:p>
         </p:txBody>

</xml_diff>